<commit_message>
Update author name across docs, data, and deck
</commit_message>
<xml_diff>
--- a/Initiative-Pulse-Onsite-Deck.pptx
+++ b/Initiative-Pulse-Onsite-Deck.pptx
@@ -4452,7 +4452,7 @@
                 <a:cs typeface="Calibri"/>
                 <a:sym typeface="Calibri"/>
               </a:rPr>
-              <a:t>Ademar Perez</a:t>
+              <a:t>Abel Pena</a:t>
             </a:r>
             <a:r>
               <a:rPr b="0" i="0" lang="en-US" sz="1400" u="none" cap="none" strike="noStrike">
@@ -4748,7 +4748,7 @@
                 <a:cs typeface="Calibri"/>
                 <a:sym typeface="Calibri"/>
               </a:rPr>
-              <a:t>Initiative Pulse  ·  JKLM Product Operations Assessment  ·  Ademar Perez</a:t>
+              <a:t>Initiative Pulse  ·  JKLM Product Operations Assessment  ·  Abel Pena</a:t>
             </a:r>
             <a:endParaRPr b="0" i="0" sz="900" u="none" cap="none" strike="noStrike">
               <a:solidFill>
@@ -6328,7 +6328,7 @@
                 <a:cs typeface="Calibri"/>
                 <a:sym typeface="Calibri"/>
               </a:rPr>
-              <a:t>Initiative Pulse  ·  JKLM Product Operations Assessment  ·  Ademar Perez</a:t>
+              <a:t>Initiative Pulse  ·  JKLM Product Operations Assessment  ·  Abel Pena</a:t>
             </a:r>
             <a:endParaRPr b="0" i="0" sz="900" u="none" cap="none" strike="noStrike">
               <a:solidFill>
@@ -7972,7 +7972,7 @@
                 <a:cs typeface="Calibri"/>
                 <a:sym typeface="Calibri"/>
               </a:rPr>
-              <a:t>Initiative Pulse  ·  JKLM Product Operations Assessment  ·  Ademar Perez</a:t>
+              <a:t>Initiative Pulse  ·  JKLM Product Operations Assessment  ·  Abel Pena</a:t>
             </a:r>
             <a:endParaRPr b="0" i="0" sz="900" u="none" cap="none" strike="noStrike">
               <a:solidFill>
@@ -9339,7 +9339,7 @@
                 <a:cs typeface="Calibri"/>
                 <a:sym typeface="Calibri"/>
               </a:rPr>
-              <a:t>Initiative Pulse  ·  JKLM Product Operations Assessment  ·  Ademar Perez</a:t>
+              <a:t>Initiative Pulse  ·  JKLM Product Operations Assessment  ·  Abel Pena</a:t>
             </a:r>
             <a:endParaRPr b="0" i="0" sz="900" u="none" cap="none" strike="noStrike">
               <a:solidFill>
@@ -11004,7 +11004,7 @@
                 <a:cs typeface="Calibri"/>
                 <a:sym typeface="Calibri"/>
               </a:rPr>
-              <a:t>Initiative Pulse  ·  JKLM Product Operations Assessment  ·  Ademar Perez</a:t>
+              <a:t>Initiative Pulse  ·  JKLM Product Operations Assessment  ·  Abel Pena</a:t>
             </a:r>
             <a:endParaRPr b="0" i="0" sz="900" u="none" cap="none" strike="noStrike">
               <a:solidFill>
@@ -12776,7 +12776,7 @@
                 <a:cs typeface="Calibri"/>
                 <a:sym typeface="Calibri"/>
               </a:rPr>
-              <a:t>Initiative Pulse  ·  JKLM Product Operations Assessment  ·  Ademar Perez</a:t>
+              <a:t>Initiative Pulse  ·  JKLM Product Operations Assessment  ·  Abel Pena</a:t>
             </a:r>
             <a:endParaRPr b="0" i="0" sz="900" u="none" cap="none" strike="noStrike">
               <a:solidFill>
@@ -14551,7 +14551,7 @@
                 <a:cs typeface="Calibri"/>
                 <a:sym typeface="Calibri"/>
               </a:rPr>
-              <a:t>Initiative Pulse  ·  JKLM Product Operations Assessment  ·  Ademar Perez</a:t>
+              <a:t>Initiative Pulse  ·  JKLM Product Operations Assessment  ·  Abel Pena</a:t>
             </a:r>
             <a:endParaRPr b="0" i="0" sz="900" u="none" cap="none" strike="noStrike">
               <a:solidFill>
@@ -16537,7 +16537,7 @@
                 <a:cs typeface="Calibri"/>
                 <a:sym typeface="Calibri"/>
               </a:rPr>
-              <a:t>Initiative Pulse  ·  JKLM Product Operations Assessment  ·  Ademar Perez</a:t>
+              <a:t>Initiative Pulse  ·  JKLM Product Operations Assessment  ·  Abel Pena</a:t>
             </a:r>
             <a:endParaRPr b="0" i="0" sz="900" u="none" cap="none" strike="noStrike">
               <a:solidFill>
@@ -18380,7 +18380,7 @@
                 <a:cs typeface="Calibri"/>
                 <a:sym typeface="Calibri"/>
               </a:rPr>
-              <a:t>Initiative Pulse  ·  JKLM Product Operations Assessment  ·  Ademar Perez</a:t>
+              <a:t>Initiative Pulse  ·  JKLM Product Operations Assessment  ·  Abel Pena</a:t>
             </a:r>
             <a:endParaRPr b="0" i="0" sz="900" u="none" cap="none" strike="noStrike">
               <a:solidFill>
@@ -20223,7 +20223,7 @@
                 <a:cs typeface="Calibri"/>
                 <a:sym typeface="Calibri"/>
               </a:rPr>
-              <a:t>Initiative Pulse  ·  JKLM Product Operations Assessment  ·  Ademar Perez</a:t>
+              <a:t>Initiative Pulse  ·  JKLM Product Operations Assessment  ·  Abel Pena</a:t>
             </a:r>
             <a:endParaRPr b="0" i="0" sz="900" u="none" cap="none" strike="noStrike">
               <a:solidFill>

</xml_diff>